<commit_message>
Logos officiels DGCI + Ministère, couverture sur fond blanc
- Logo DGCI (Direção Geral das Contribuições e Impostos) en en-tête
  de chaque slide, à la place du logo DGI erroné
- Couverture : fond blanc, logo du Ministère (Economia e Finanças /
  Secretaria de Estado do Orçamento e Assuntos Fiscais) + logo DGCI
- Supports livrés en PowerPoint (sources/) et PDF
</commit_message>
<xml_diff>
--- a/slides/sources/J1-fondamentaux.pptx
+++ b/slides/sources/J1-fondamentaux.pptx
@@ -1569,7 +1569,7 @@
     <p:bg>
       <p:bgPr>
         <a:solidFill>
-          <a:srgbClr val="0A2E1A"/>
+          <a:srgbClr val="FFFFFF"/>
         </a:solidFill>
       </p:bgPr>
     </p:bg>
@@ -1595,14 +1595,14 @@
         </p:nvSpPr>
         <p:spPr>
           <a:xfrm>
-            <a:off x="9692640" y="-1463040"/>
-            <a:ext cx="4206240" cy="4206240"/>
+            <a:off x="10149840" y="4846320"/>
+            <a:ext cx="3291840" cy="3291840"/>
           </a:xfrm>
           <a:prstGeom prst="ellipse">
             <a:avLst/>
           </a:prstGeom>
           <a:solidFill>
-            <a:srgbClr val="0E7A3D"/>
+            <a:srgbClr val="EEF5EF"/>
           </a:solidFill>
           <a:ln/>
         </p:spPr>
@@ -1615,67 +1615,21 @@
         </p:nvSpPr>
         <p:spPr>
           <a:xfrm>
-            <a:off x="10698480" y="4480560"/>
-            <a:ext cx="3108960" cy="3108960"/>
+            <a:off x="-1188720" y="-1371600"/>
+            <a:ext cx="2743200" cy="2743200"/>
           </a:xfrm>
           <a:prstGeom prst="ellipse">
             <a:avLst/>
           </a:prstGeom>
           <a:solidFill>
-            <a:srgbClr val="FCD116">
-              <a:alpha val="55000"/>
-            </a:srgbClr>
-          </a:solidFill>
-          <a:ln/>
-        </p:spPr>
-      </p:sp>
-      <p:sp>
-        <p:nvSpPr>
-          <p:cNvPr id="4" name="Shape 2"/>
-          <p:cNvSpPr/>
-          <p:nvPr/>
-        </p:nvSpPr>
-        <p:spPr>
-          <a:xfrm>
-            <a:off x="-1097280" y="5120640"/>
-            <a:ext cx="2743200" cy="2743200"/>
-          </a:xfrm>
-          <a:prstGeom prst="ellipse">
-            <a:avLst/>
-          </a:prstGeom>
-          <a:solidFill>
-            <a:srgbClr val="CE1126">
-              <a:alpha val="65000"/>
-            </a:srgbClr>
-          </a:solidFill>
-          <a:ln/>
-        </p:spPr>
-      </p:sp>
-      <p:sp>
-        <p:nvSpPr>
-          <p:cNvPr id="5" name="Shape 3"/>
-          <p:cNvSpPr/>
-          <p:nvPr/>
-        </p:nvSpPr>
-        <p:spPr>
-          <a:xfrm>
-            <a:off x="9464040" y="502920"/>
-            <a:ext cx="2148840" cy="1828800"/>
-          </a:xfrm>
-          <a:prstGeom prst="roundRect">
-            <a:avLst>
-              <a:gd name="adj" fmla="val 6000"/>
-            </a:avLst>
-          </a:prstGeom>
-          <a:solidFill>
-            <a:srgbClr val="FFFFFF"/>
+            <a:srgbClr val="EEF5EF"/>
           </a:solidFill>
           <a:ln/>
         </p:spPr>
       </p:sp>
       <p:pic>
         <p:nvPicPr>
-          <p:cNvPr id="6" name="Image 0" descr="logo-dgi.png">    </p:cNvPr>
+          <p:cNvPr id="4" name="Image 0" descr="logo-ministere.png">    </p:cNvPr>
           <p:cNvPicPr>
             <a:picLocks noChangeAspect="1"/>
           </p:cNvPicPr>
@@ -1689,23 +1643,47 @@
         </p:blipFill>
         <p:spPr>
           <a:xfrm>
-            <a:off x="9646920" y="740664"/>
-            <a:ext cx="1783080" cy="1353312"/>
+            <a:off x="640080" y="457200"/>
+            <a:ext cx="4206240" cy="822960"/>
           </a:xfrm>
           <a:prstGeom prst="rect">
             <a:avLst/>
           </a:prstGeom>
         </p:spPr>
       </p:pic>
-      <p:sp>
-        <p:nvSpPr>
-          <p:cNvPr id="7" name="Text 4"/>
-          <p:cNvSpPr/>
-          <p:nvPr/>
-        </p:nvSpPr>
-        <p:spPr>
-          <a:xfrm>
-            <a:off x="640080" y="777240"/>
+      <p:pic>
+        <p:nvPicPr>
+          <p:cNvPr id="5" name="Image 1" descr="logo-dgci.png">    </p:cNvPr>
+          <p:cNvPicPr>
+            <a:picLocks noChangeAspect="1"/>
+          </p:cNvPicPr>
+          <p:nvPr/>
+        </p:nvPicPr>
+        <p:blipFill>
+          <a:blip r:embed="rId2"/>
+          <a:stretch>
+            <a:fillRect/>
+          </a:stretch>
+        </p:blipFill>
+        <p:spPr>
+          <a:xfrm>
+            <a:off x="9144000" y="475488"/>
+            <a:ext cx="2468880" cy="758952"/>
+          </a:xfrm>
+          <a:prstGeom prst="rect">
+            <a:avLst/>
+          </a:prstGeom>
+        </p:spPr>
+      </p:pic>
+      <p:sp>
+        <p:nvSpPr>
+          <p:cNvPr id="6" name="Text 2"/>
+          <p:cNvSpPr/>
+          <p:nvPr/>
+        </p:nvSpPr>
+        <p:spPr>
+          <a:xfrm>
+            <a:off x="640080" y="1874520"/>
             <a:ext cx="7315200" cy="365760"/>
           </a:xfrm>
           <a:prstGeom prst="rect">
@@ -1724,7 +1702,7 @@
             <a:r>
               <a:rPr lang="en-US" sz="1500" b="1" spc="300" kern="0" dirty="0">
                 <a:solidFill>
-                  <a:srgbClr val="FCD116"/>
+                  <a:srgbClr val="C79100"/>
                 </a:solidFill>
                 <a:latin typeface="Calibri" pitchFamily="34" charset="0"/>
                 <a:ea typeface="Calibri" pitchFamily="34" charset="-122"/>
@@ -1738,13 +1716,13 @@
       </p:sp>
       <p:sp>
         <p:nvSpPr>
-          <p:cNvPr id="8" name="Text 5"/>
-          <p:cNvSpPr/>
-          <p:nvPr/>
-        </p:nvSpPr>
-        <p:spPr>
-          <a:xfrm>
-            <a:off x="640080" y="1417320"/>
+          <p:cNvPr id="7" name="Text 3"/>
+          <p:cNvSpPr/>
+          <p:nvPr/>
+        </p:nvSpPr>
+        <p:spPr>
+          <a:xfrm>
+            <a:off x="640080" y="2286000"/>
             <a:ext cx="8686800" cy="1371600"/>
           </a:xfrm>
           <a:prstGeom prst="rect">
@@ -1761,9 +1739,9 @@
               <a:buNone/>
             </a:pPr>
             <a:r>
-              <a:rPr lang="en-US" sz="8400" b="1" dirty="0">
-                <a:solidFill>
-                  <a:srgbClr val="FFFFFF"/>
+              <a:rPr lang="en-US" sz="8000" b="1" dirty="0">
+                <a:solidFill>
+                  <a:srgbClr val="0E7A3D"/>
                 </a:solidFill>
                 <a:latin typeface="Cambria" pitchFamily="34" charset="0"/>
                 <a:ea typeface="Cambria" pitchFamily="34" charset="-122"/>
@@ -1771,20 +1749,20 @@
               </a:rPr>
               <a:t>J1</a:t>
             </a:r>
-            <a:endParaRPr lang="en-US" sz="8400" dirty="0"/>
-          </a:p>
-        </p:txBody>
-      </p:sp>
-      <p:sp>
-        <p:nvSpPr>
-          <p:cNvPr id="9" name="Text 6"/>
-          <p:cNvSpPr/>
-          <p:nvPr/>
-        </p:nvSpPr>
-        <p:spPr>
-          <a:xfrm>
-            <a:off x="640080" y="2880360"/>
-            <a:ext cx="9418320" cy="914400"/>
+            <a:endParaRPr lang="en-US" sz="8000" dirty="0"/>
+          </a:p>
+        </p:txBody>
+      </p:sp>
+      <p:sp>
+        <p:nvSpPr>
+          <p:cNvPr id="8" name="Text 4"/>
+          <p:cNvSpPr/>
+          <p:nvPr/>
+        </p:nvSpPr>
+        <p:spPr>
+          <a:xfrm>
+            <a:off x="640080" y="3657600"/>
+            <a:ext cx="10058400" cy="914400"/>
           </a:xfrm>
           <a:prstGeom prst="rect">
             <a:avLst/>
@@ -1800,9 +1778,9 @@
               <a:buNone/>
             </a:pPr>
             <a:r>
-              <a:rPr lang="en-US" sz="3500" b="1" dirty="0">
-                <a:solidFill>
-                  <a:srgbClr val="FCD116"/>
+              <a:rPr lang="en-US" sz="3400" b="1" dirty="0">
+                <a:solidFill>
+                  <a:srgbClr val="1C2A24"/>
                 </a:solidFill>
                 <a:latin typeface="Cambria" pitchFamily="34" charset="0"/>
                 <a:ea typeface="Cambria" pitchFamily="34" charset="-122"/>
@@ -1810,20 +1788,20 @@
               </a:rPr>
               <a:t>Fondamentaux du langage</a:t>
             </a:r>
-            <a:endParaRPr lang="en-US" sz="3500" dirty="0"/>
-          </a:p>
-        </p:txBody>
-      </p:sp>
-      <p:sp>
-        <p:nvSpPr>
-          <p:cNvPr id="10" name="Text 7"/>
-          <p:cNvSpPr/>
-          <p:nvPr/>
-        </p:nvSpPr>
-        <p:spPr>
-          <a:xfrm>
-            <a:off x="640080" y="3794760"/>
-            <a:ext cx="8778240" cy="822960"/>
+            <a:endParaRPr lang="en-US" sz="3400" dirty="0"/>
+          </a:p>
+        </p:txBody>
+      </p:sp>
+      <p:sp>
+        <p:nvSpPr>
+          <p:cNvPr id="9" name="Text 5"/>
+          <p:cNvSpPr/>
+          <p:nvPr/>
+        </p:nvSpPr>
+        <p:spPr>
+          <a:xfrm>
+            <a:off x="640080" y="4526280"/>
+            <a:ext cx="9326880" cy="822960"/>
           </a:xfrm>
           <a:prstGeom prst="rect">
             <a:avLst/>
@@ -1842,9 +1820,9 @@
               <a:buNone/>
             </a:pPr>
             <a:r>
-              <a:rPr lang="en-US" sz="1600" dirty="0">
-                <a:solidFill>
-                  <a:srgbClr val="CADFD2"/>
+              <a:rPr lang="en-US" sz="1550" dirty="0">
+                <a:solidFill>
+                  <a:srgbClr val="5C6B63"/>
                 </a:solidFill>
                 <a:latin typeface="Calibri" pitchFamily="34" charset="0"/>
                 <a:ea typeface="Calibri" pitchFamily="34" charset="-122"/>
@@ -1852,7 +1830,7 @@
               </a:rPr>
               <a:t>Prendre en main l’environnement, manipuler les types de base,</a:t>
             </a:r>
-            <a:endParaRPr lang="en-US" sz="1600" dirty="0"/>
+            <a:endParaRPr lang="en-US" sz="1550" dirty="0"/>
           </a:p>
           <a:p>
             <a:pPr indent="0" marL="0">
@@ -1862,9 +1840,9 @@
               <a:buNone/>
             </a:pPr>
             <a:r>
-              <a:rPr lang="en-US" sz="1600" dirty="0">
-                <a:solidFill>
-                  <a:srgbClr val="CADFD2"/>
+              <a:rPr lang="en-US" sz="1550" dirty="0">
+                <a:solidFill>
+                  <a:srgbClr val="5C6B63"/>
                 </a:solidFill>
                 <a:latin typeface="Calibri" pitchFamily="34" charset="0"/>
                 <a:ea typeface="Calibri" pitchFamily="34" charset="-122"/>
@@ -1872,19 +1850,19 @@
               </a:rPr>
               <a:t>écrire ses premières conditions et boucles.</a:t>
             </a:r>
-            <a:endParaRPr lang="en-US" sz="1600" dirty="0"/>
-          </a:p>
-        </p:txBody>
-      </p:sp>
-      <p:sp>
-        <p:nvSpPr>
-          <p:cNvPr id="11" name="Shape 8"/>
-          <p:cNvSpPr/>
-          <p:nvPr/>
-        </p:nvSpPr>
-        <p:spPr>
-          <a:xfrm>
-            <a:off x="640080" y="5120640"/>
+            <a:endParaRPr lang="en-US" sz="1550" dirty="0"/>
+          </a:p>
+        </p:txBody>
+      </p:sp>
+      <p:sp>
+        <p:nvSpPr>
+          <p:cNvPr id="10" name="Shape 6"/>
+          <p:cNvSpPr/>
+          <p:nvPr/>
+        </p:nvSpPr>
+        <p:spPr>
+          <a:xfrm>
+            <a:off x="640080" y="5440680"/>
             <a:ext cx="1824228" cy="475488"/>
           </a:xfrm>
           <a:prstGeom prst="roundRect">
@@ -1900,13 +1878,13 @@
       </p:sp>
       <p:sp>
         <p:nvSpPr>
-          <p:cNvPr id="12" name="Text 9"/>
-          <p:cNvSpPr/>
-          <p:nvPr/>
-        </p:nvSpPr>
-        <p:spPr>
-          <a:xfrm>
-            <a:off x="640080" y="5120640"/>
+          <p:cNvPr id="11" name="Text 7"/>
+          <p:cNvSpPr/>
+          <p:nvPr/>
+        </p:nvSpPr>
+        <p:spPr>
+          <a:xfrm>
+            <a:off x="640080" y="5440680"/>
             <a:ext cx="1824228" cy="475488"/>
           </a:xfrm>
           <a:prstGeom prst="rect">
@@ -1939,13 +1917,13 @@
       </p:sp>
       <p:sp>
         <p:nvSpPr>
-          <p:cNvPr id="13" name="Shape 10"/>
-          <p:cNvSpPr/>
-          <p:nvPr/>
-        </p:nvSpPr>
-        <p:spPr>
-          <a:xfrm>
-            <a:off x="2692908" y="5120640"/>
+          <p:cNvPr id="12" name="Shape 8"/>
+          <p:cNvSpPr/>
+          <p:nvPr/>
+        </p:nvSpPr>
+        <p:spPr>
+          <a:xfrm>
+            <a:off x="2692908" y="5440680"/>
             <a:ext cx="2208276" cy="475488"/>
           </a:xfrm>
           <a:prstGeom prst="roundRect">
@@ -1961,13 +1939,13 @@
       </p:sp>
       <p:sp>
         <p:nvSpPr>
-          <p:cNvPr id="14" name="Text 11"/>
-          <p:cNvSpPr/>
-          <p:nvPr/>
-        </p:nvSpPr>
-        <p:spPr>
-          <a:xfrm>
-            <a:off x="2692908" y="5120640"/>
+          <p:cNvPr id="13" name="Text 9"/>
+          <p:cNvSpPr/>
+          <p:nvPr/>
+        </p:nvSpPr>
+        <p:spPr>
+          <a:xfrm>
+            <a:off x="2692908" y="5440680"/>
             <a:ext cx="2208276" cy="475488"/>
           </a:xfrm>
           <a:prstGeom prst="rect">
@@ -2000,14 +1978,14 @@
       </p:sp>
       <p:sp>
         <p:nvSpPr>
-          <p:cNvPr id="15" name="Text 12"/>
-          <p:cNvSpPr/>
-          <p:nvPr/>
-        </p:nvSpPr>
-        <p:spPr>
-          <a:xfrm>
-            <a:off x="640080" y="6172200"/>
-            <a:ext cx="10058400" cy="320040"/>
+          <p:cNvPr id="14" name="Text 10"/>
+          <p:cNvSpPr/>
+          <p:nvPr/>
+        </p:nvSpPr>
+        <p:spPr>
+          <a:xfrm>
+            <a:off x="640080" y="6263640"/>
+            <a:ext cx="10972800" cy="320040"/>
           </a:xfrm>
           <a:prstGeom prst="rect">
             <a:avLst/>
@@ -2023,17 +2001,17 @@
               <a:buNone/>
             </a:pPr>
             <a:r>
-              <a:rPr lang="en-US" sz="1200" dirty="0">
-                <a:solidFill>
-                  <a:srgbClr val="8FAF9F"/>
+              <a:rPr lang="en-US" sz="1150" dirty="0">
+                <a:solidFill>
+                  <a:srgbClr val="5C6B63"/>
                 </a:solidFill>
                 <a:latin typeface="Calibri" pitchFamily="34" charset="0"/>
                 <a:ea typeface="Calibri" pitchFamily="34" charset="-122"/>
                 <a:cs typeface="Calibri" pitchFamily="34" charset="-120"/>
               </a:rPr>
-              <a:t>DGI — Direction Générale des Impôts · Guinée-Bissau · données pédagogiques fictives</a:t>
-            </a:r>
-            <a:endParaRPr lang="en-US" sz="1200" dirty="0"/>
+              <a:t>DGCI — Direção Geral das Contribuições e Impostos · Guinée-Bissau · données pédagogiques fictives</a:t>
+            </a:r>
+            <a:endParaRPr lang="en-US" sz="1150" dirty="0"/>
           </a:p>
         </p:txBody>
       </p:sp>
@@ -2149,7 +2127,7 @@
       </p:sp>
       <p:pic>
         <p:nvPicPr>
-          <p:cNvPr id="4" name="Image 0" descr="logo-dgi.png">    </p:cNvPr>
+          <p:cNvPr id="4" name="Image 0" descr="logo-dgci.png">    </p:cNvPr>
           <p:cNvPicPr>
             <a:picLocks noChangeAspect="1"/>
           </p:cNvPicPr>
@@ -2163,8 +2141,8 @@
         </p:blipFill>
         <p:spPr>
           <a:xfrm>
-            <a:off x="10744200" y="384048"/>
-            <a:ext cx="1051560" cy="795528"/>
+            <a:off x="10287000" y="475488"/>
+            <a:ext cx="1481328" cy="457200"/>
           </a:xfrm>
           <a:prstGeom prst="rect">
             <a:avLst/>
@@ -3361,7 +3339,7 @@
       </p:sp>
       <p:pic>
         <p:nvPicPr>
-          <p:cNvPr id="4" name="Image 0" descr="logo-dgi.png">    </p:cNvPr>
+          <p:cNvPr id="4" name="Image 0" descr="logo-dgci.png">    </p:cNvPr>
           <p:cNvPicPr>
             <a:picLocks noChangeAspect="1"/>
           </p:cNvPicPr>
@@ -3375,8 +3353,8 @@
         </p:blipFill>
         <p:spPr>
           <a:xfrm>
-            <a:off x="10744200" y="384048"/>
-            <a:ext cx="1051560" cy="795528"/>
+            <a:off x="10287000" y="475488"/>
+            <a:ext cx="1481328" cy="457200"/>
           </a:xfrm>
           <a:prstGeom prst="rect">
             <a:avLst/>
@@ -4227,7 +4205,7 @@
       </p:sp>
       <p:pic>
         <p:nvPicPr>
-          <p:cNvPr id="4" name="Image 0" descr="logo-dgi.png">    </p:cNvPr>
+          <p:cNvPr id="4" name="Image 0" descr="logo-dgci.png">    </p:cNvPr>
           <p:cNvPicPr>
             <a:picLocks noChangeAspect="1"/>
           </p:cNvPicPr>
@@ -4241,8 +4219,8 @@
         </p:blipFill>
         <p:spPr>
           <a:xfrm>
-            <a:off x="10744200" y="384048"/>
-            <a:ext cx="1051560" cy="795528"/>
+            <a:off x="10287000" y="475488"/>
+            <a:ext cx="1481328" cy="457200"/>
           </a:xfrm>
           <a:prstGeom prst="rect">
             <a:avLst/>
@@ -5338,7 +5316,7 @@
       </p:sp>
       <p:pic>
         <p:nvPicPr>
-          <p:cNvPr id="4" name="Image 0" descr="logo-dgi.png">    </p:cNvPr>
+          <p:cNvPr id="4" name="Image 0" descr="logo-dgci.png">    </p:cNvPr>
           <p:cNvPicPr>
             <a:picLocks noChangeAspect="1"/>
           </p:cNvPicPr>
@@ -5352,8 +5330,8 @@
         </p:blipFill>
         <p:spPr>
           <a:xfrm>
-            <a:off x="10744200" y="384048"/>
-            <a:ext cx="1051560" cy="795528"/>
+            <a:off x="10287000" y="475488"/>
+            <a:ext cx="1481328" cy="457200"/>
           </a:xfrm>
           <a:prstGeom prst="rect">
             <a:avLst/>
@@ -6497,7 +6475,7 @@
       </p:sp>
       <p:pic>
         <p:nvPicPr>
-          <p:cNvPr id="4" name="Image 0" descr="logo-dgi.png">    </p:cNvPr>
+          <p:cNvPr id="4" name="Image 0" descr="logo-dgci.png">    </p:cNvPr>
           <p:cNvPicPr>
             <a:picLocks noChangeAspect="1"/>
           </p:cNvPicPr>
@@ -6511,8 +6489,8 @@
         </p:blipFill>
         <p:spPr>
           <a:xfrm>
-            <a:off x="10744200" y="384048"/>
-            <a:ext cx="1051560" cy="795528"/>
+            <a:off x="10287000" y="475488"/>
+            <a:ext cx="1481328" cy="457200"/>
           </a:xfrm>
           <a:prstGeom prst="rect">
             <a:avLst/>
@@ -7916,7 +7894,7 @@
       </p:sp>
       <p:pic>
         <p:nvPicPr>
-          <p:cNvPr id="4" name="Image 0" descr="logo-dgi.png">    </p:cNvPr>
+          <p:cNvPr id="4" name="Image 0" descr="logo-dgci.png">    </p:cNvPr>
           <p:cNvPicPr>
             <a:picLocks noChangeAspect="1"/>
           </p:cNvPicPr>
@@ -7930,8 +7908,8 @@
         </p:blipFill>
         <p:spPr>
           <a:xfrm>
-            <a:off x="10744200" y="384048"/>
-            <a:ext cx="1051560" cy="795528"/>
+            <a:off x="10287000" y="475488"/>
+            <a:ext cx="1481328" cy="457200"/>
           </a:xfrm>
           <a:prstGeom prst="rect">
             <a:avLst/>
@@ -9156,7 +9134,7 @@
       </p:sp>
       <p:pic>
         <p:nvPicPr>
-          <p:cNvPr id="4" name="Image 0" descr="logo-dgi.png">    </p:cNvPr>
+          <p:cNvPr id="4" name="Image 0" descr="logo-dgci.png">    </p:cNvPr>
           <p:cNvPicPr>
             <a:picLocks noChangeAspect="1"/>
           </p:cNvPicPr>
@@ -9170,8 +9148,8 @@
         </p:blipFill>
         <p:spPr>
           <a:xfrm>
-            <a:off x="10744200" y="384048"/>
-            <a:ext cx="1051560" cy="795528"/>
+            <a:off x="10287000" y="475488"/>
+            <a:ext cx="1481328" cy="457200"/>
           </a:xfrm>
           <a:prstGeom prst="rect">
             <a:avLst/>

</xml_diff>